<commit_message>
Update investment slide with the official approved figures
Replace estimated ranges with the exact 6-line breakdown from the signed
Plan de Inversión (Contrato interadministrativo #4600107420 de 2026):
DevOps/escalabilidad, licencia IA, créditos API, 14 dispositivos de audio,
marketing/branding, y registro de marca — total $15.000.000.
</commit_message>
<xml_diff>
--- a/miracle_capital_semilla_pitch.pptx
+++ b/miracle_capital_semilla_pitch.pptx
@@ -4177,7 +4177,7 @@
           </p:nvPr>
         </p:nvGraphicFramePr>
         <p:xfrm>
-          <a:off x="502920" y="1554480"/>
+          <a:off x="502920" y="1481328"/>
           <a:ext cx="8138160" cy="914400"/>
         </p:xfrm>
         <a:graphic>
@@ -4189,7 +4189,7 @@
                 <a:gridCol w="1464869"/>
                 <a:gridCol w="3255264"/>
               </a:tblGrid>
-              <a:tr h="384048">
+              <a:tr h="333756">
                 <a:tc>
                   <a:txBody>
                     <a:bodyPr/>
@@ -4199,17 +4199,148 @@
                         <a:buNone/>
                       </a:pPr>
                       <a:r>
-                        <a:rPr lang="en-US" sz="950" b="1" dirty="0">
+                        <a:rPr lang="en-US" sz="850" b="1" dirty="0">
                           <a:solidFill>
                             <a:srgbClr val="6E6E73"/>
                           </a:solidFill>
                         </a:rPr>
                         <a:t>Inversión</a:t>
                       </a:r>
+                      <a:endParaRPr lang="en-US" sz="850" dirty="0"/>
+                    </a:p>
+                  </a:txBody>
+                  <a:tcPr marL="101600" marR="101600" marT="50800" marB="50800" anchor="ctr">
+                    <a:lnL w="0" cap="flat" cmpd="sng" algn="ctr">
+                      <a:noFill/>
+                    </a:lnL>
+                    <a:lnR w="0" cap="flat" cmpd="sng" algn="ctr">
+                      <a:noFill/>
+                    </a:lnR>
+                    <a:lnT w="0" cap="flat" cmpd="sng" algn="ctr">
+                      <a:noFill/>
+                    </a:lnT>
+                    <a:lnB w="9525" cap="flat" cmpd="sng" algn="ctr">
+                      <a:solidFill>
+                        <a:srgbClr val="E2E2E6"/>
+                      </a:solidFill>
+                      <a:prstDash val="solid"/>
+                      <a:round/>
+                      <a:headEnd type="none" w="med" len="med"/>
+                      <a:tailEnd type="none" w="med" len="med"/>
+                    </a:lnB>
+                    <a:solidFill>
+                      <a:srgbClr val="FFFFFF"/>
+                    </a:solidFill>
+                  </a:tcPr>
+                </a:tc>
+                <a:tc>
+                  <a:txBody>
+                    <a:bodyPr/>
+                    <a:lstStyle/>
+                    <a:p>
+                      <a:pPr indent="0" marL="0">
+                        <a:buNone/>
+                      </a:pPr>
+                      <a:r>
+                        <a:rPr lang="en-US" sz="850" b="1" dirty="0">
+                          <a:solidFill>
+                            <a:srgbClr val="6E6E73"/>
+                          </a:solidFill>
+                        </a:rPr>
+                        <a:t>Monto aprobado</a:t>
+                      </a:r>
+                      <a:endParaRPr lang="en-US" sz="850" dirty="0"/>
+                    </a:p>
+                  </a:txBody>
+                  <a:tcPr marL="101600" marR="101600" marT="50800" marB="50800" anchor="ctr">
+                    <a:lnL w="0" cap="flat" cmpd="sng" algn="ctr">
+                      <a:noFill/>
+                    </a:lnL>
+                    <a:lnR w="0" cap="flat" cmpd="sng" algn="ctr">
+                      <a:noFill/>
+                    </a:lnR>
+                    <a:lnT w="0" cap="flat" cmpd="sng" algn="ctr">
+                      <a:noFill/>
+                    </a:lnT>
+                    <a:lnB w="9525" cap="flat" cmpd="sng" algn="ctr">
+                      <a:solidFill>
+                        <a:srgbClr val="E2E2E6"/>
+                      </a:solidFill>
+                      <a:prstDash val="solid"/>
+                      <a:round/>
+                      <a:headEnd type="none" w="med" len="med"/>
+                      <a:tailEnd type="none" w="med" len="med"/>
+                    </a:lnB>
+                    <a:solidFill>
+                      <a:srgbClr val="FFFFFF"/>
+                    </a:solidFill>
+                  </a:tcPr>
+                </a:tc>
+                <a:tc>
+                  <a:txBody>
+                    <a:bodyPr/>
+                    <a:lstStyle/>
+                    <a:p>
+                      <a:pPr indent="0" marL="0">
+                        <a:buNone/>
+                      </a:pPr>
+                      <a:r>
+                        <a:rPr lang="en-US" sz="850" b="1" dirty="0">
+                          <a:solidFill>
+                            <a:srgbClr val="6E6E73"/>
+                          </a:solidFill>
+                        </a:rPr>
+                        <a:t>Objetivo</a:t>
+                      </a:r>
+                      <a:endParaRPr lang="en-US" sz="850" dirty="0"/>
+                    </a:p>
+                  </a:txBody>
+                  <a:tcPr marL="101600" marR="101600" marT="50800" marB="50800" anchor="ctr">
+                    <a:lnL w="0" cap="flat" cmpd="sng" algn="ctr">
+                      <a:noFill/>
+                    </a:lnL>
+                    <a:lnR w="0" cap="flat" cmpd="sng" algn="ctr">
+                      <a:noFill/>
+                    </a:lnR>
+                    <a:lnT w="0" cap="flat" cmpd="sng" algn="ctr">
+                      <a:noFill/>
+                    </a:lnT>
+                    <a:lnB w="9525" cap="flat" cmpd="sng" algn="ctr">
+                      <a:solidFill>
+                        <a:srgbClr val="E2E2E6"/>
+                      </a:solidFill>
+                      <a:prstDash val="solid"/>
+                      <a:round/>
+                      <a:headEnd type="none" w="med" len="med"/>
+                      <a:tailEnd type="none" w="med" len="med"/>
+                    </a:lnB>
+                    <a:solidFill>
+                      <a:srgbClr val="FFFFFF"/>
+                    </a:solidFill>
+                  </a:tcPr>
+                </a:tc>
+              </a:tr>
+              <a:tr h="333756">
+                <a:tc>
+                  <a:txBody>
+                    <a:bodyPr/>
+                    <a:lstStyle/>
+                    <a:p>
+                      <a:pPr indent="0" marL="0">
+                        <a:buNone/>
+                      </a:pPr>
+                      <a:r>
+                        <a:rPr lang="en-US" sz="950" dirty="0">
+                          <a:solidFill>
+                            <a:srgbClr val="1D1D1F"/>
+                          </a:solidFill>
+                        </a:rPr>
+                        <a:t>Asesoría técnica DevOps, escalabilidad y despliegue cloud</a:t>
+                      </a:r>
                       <a:endParaRPr lang="en-US" sz="950" dirty="0"/>
                     </a:p>
                   </a:txBody>
-                  <a:tcPr marL="127000" marR="127000" marT="63500" marB="63500" anchor="ctr">
+                  <a:tcPr marL="101600" marR="101600" marT="50800" marB="50800" anchor="ctr">
                     <a:lnL w="0" cap="flat" cmpd="sng" algn="ctr">
                       <a:noFill/>
                     </a:lnL>
@@ -4244,15 +4375,110 @@
                       <a:r>
                         <a:rPr lang="en-US" sz="950" b="1" dirty="0">
                           <a:solidFill>
-                            <a:srgbClr val="6E6E73"/>
+                            <a:srgbClr val="0071E3"/>
+                          </a:solidFill>
+                          <a:latin typeface="Arial" pitchFamily="34" charset="0"/>
+                          <a:ea typeface="Arial" pitchFamily="34" charset="-122"/>
+                          <a:cs typeface="Arial" pitchFamily="34" charset="-120"/>
+                        </a:rPr>
+                        <a:t>$4.000.000</a:t>
+                      </a:r>
+                      <a:endParaRPr lang="en-US" sz="950" dirty="0">
+                        <a:latin typeface="Arial" charset="0"/>
+                        <a:ea typeface="Arial" charset="0"/>
+                        <a:cs typeface="Arial" charset="0"/>
+                      </a:endParaRPr>
+                    </a:p>
+                  </a:txBody>
+                  <a:tcPr marL="101600" marR="101600" marT="50800" marB="50800" anchor="ctr">
+                    <a:lnL w="0" cap="flat" cmpd="sng" algn="ctr">
+                      <a:noFill/>
+                    </a:lnL>
+                    <a:lnR w="0" cap="flat" cmpd="sng" algn="ctr">
+                      <a:noFill/>
+                    </a:lnR>
+                    <a:lnT w="0" cap="flat" cmpd="sng" algn="ctr">
+                      <a:noFill/>
+                    </a:lnT>
+                    <a:lnB w="9525" cap="flat" cmpd="sng" algn="ctr">
+                      <a:solidFill>
+                        <a:srgbClr val="E2E2E6"/>
+                      </a:solidFill>
+                      <a:prstDash val="solid"/>
+                      <a:round/>
+                      <a:headEnd type="none" w="med" len="med"/>
+                      <a:tailEnd type="none" w="med" len="med"/>
+                    </a:lnB>
+                    <a:solidFill>
+                      <a:srgbClr val="FFFFFF"/>
+                    </a:solidFill>
+                  </a:tcPr>
+                </a:tc>
+                <a:tc>
+                  <a:txBody>
+                    <a:bodyPr/>
+                    <a:lstStyle/>
+                    <a:p>
+                      <a:pPr indent="0" marL="0">
+                        <a:buNone/>
+                      </a:pPr>
+                      <a:r>
+                        <a:rPr lang="en-US" sz="950" dirty="0">
+                          <a:solidFill>
+                            <a:srgbClr val="48484A"/>
                           </a:solidFill>
                         </a:rPr>
-                        <a:t>Monto sugerido</a:t>
+                        <a:t>Estabilidad y disponibilidad del PMV para pruebas reales</a:t>
                       </a:r>
                       <a:endParaRPr lang="en-US" sz="950" dirty="0"/>
                     </a:p>
                   </a:txBody>
-                  <a:tcPr marL="127000" marR="127000" marT="63500" marB="63500" anchor="ctr">
+                  <a:tcPr marL="101600" marR="101600" marT="50800" marB="50800" anchor="ctr">
+                    <a:lnL w="0" cap="flat" cmpd="sng" algn="ctr">
+                      <a:noFill/>
+                    </a:lnL>
+                    <a:lnR w="0" cap="flat" cmpd="sng" algn="ctr">
+                      <a:noFill/>
+                    </a:lnR>
+                    <a:lnT w="0" cap="flat" cmpd="sng" algn="ctr">
+                      <a:noFill/>
+                    </a:lnT>
+                    <a:lnB w="9525" cap="flat" cmpd="sng" algn="ctr">
+                      <a:solidFill>
+                        <a:srgbClr val="E2E2E6"/>
+                      </a:solidFill>
+                      <a:prstDash val="solid"/>
+                      <a:round/>
+                      <a:headEnd type="none" w="med" len="med"/>
+                      <a:tailEnd type="none" w="med" len="med"/>
+                    </a:lnB>
+                    <a:solidFill>
+                      <a:srgbClr val="FFFFFF"/>
+                    </a:solidFill>
+                  </a:tcPr>
+                </a:tc>
+              </a:tr>
+              <a:tr h="333756">
+                <a:tc>
+                  <a:txBody>
+                    <a:bodyPr/>
+                    <a:lstStyle/>
+                    <a:p>
+                      <a:pPr indent="0" marL="0">
+                        <a:buNone/>
+                      </a:pPr>
+                      <a:r>
+                        <a:rPr lang="en-US" sz="950" dirty="0">
+                          <a:solidFill>
+                            <a:srgbClr val="1D1D1F"/>
+                          </a:solidFill>
+                        </a:rPr>
+                        <a:t>Licencia mensual de herramienta de IA</a:t>
+                      </a:r>
+                      <a:endParaRPr lang="en-US" sz="950" dirty="0"/>
+                    </a:p>
+                  </a:txBody>
+                  <a:tcPr marL="101600" marR="101600" marT="50800" marB="50800" anchor="ctr">
                     <a:lnL w="0" cap="flat" cmpd="sng" algn="ctr">
                       <a:noFill/>
                     </a:lnL>
@@ -4287,60 +4513,22 @@
                       <a:r>
                         <a:rPr lang="en-US" sz="950" b="1" dirty="0">
                           <a:solidFill>
-                            <a:srgbClr val="6E6E73"/>
+                            <a:srgbClr val="0071E3"/>
                           </a:solidFill>
+                          <a:latin typeface="Arial" pitchFamily="34" charset="0"/>
+                          <a:ea typeface="Arial" pitchFamily="34" charset="-122"/>
+                          <a:cs typeface="Arial" pitchFamily="34" charset="-120"/>
                         </a:rPr>
-                        <a:t>Objetivo</a:t>
+                        <a:t>$400.000</a:t>
                       </a:r>
-                      <a:endParaRPr lang="en-US" sz="950" dirty="0"/>
+                      <a:endParaRPr lang="en-US" sz="950" dirty="0">
+                        <a:latin typeface="Arial" charset="0"/>
+                        <a:ea typeface="Arial" charset="0"/>
+                        <a:cs typeface="Arial" charset="0"/>
+                      </a:endParaRPr>
                     </a:p>
                   </a:txBody>
-                  <a:tcPr marL="127000" marR="127000" marT="63500" marB="63500" anchor="ctr">
-                    <a:lnL w="0" cap="flat" cmpd="sng" algn="ctr">
-                      <a:noFill/>
-                    </a:lnL>
-                    <a:lnR w="0" cap="flat" cmpd="sng" algn="ctr">
-                      <a:noFill/>
-                    </a:lnR>
-                    <a:lnT w="0" cap="flat" cmpd="sng" algn="ctr">
-                      <a:noFill/>
-                    </a:lnT>
-                    <a:lnB w="9525" cap="flat" cmpd="sng" algn="ctr">
-                      <a:solidFill>
-                        <a:srgbClr val="E2E2E6"/>
-                      </a:solidFill>
-                      <a:prstDash val="solid"/>
-                      <a:round/>
-                      <a:headEnd type="none" w="med" len="med"/>
-                      <a:tailEnd type="none" w="med" len="med"/>
-                    </a:lnB>
-                    <a:solidFill>
-                      <a:srgbClr val="FFFFFF"/>
-                    </a:solidFill>
-                  </a:tcPr>
-                </a:tc>
-              </a:tr>
-              <a:tr h="384048">
-                <a:tc>
-                  <a:txBody>
-                    <a:bodyPr/>
-                    <a:lstStyle/>
-                    <a:p>
-                      <a:pPr indent="0" marL="0">
-                        <a:buNone/>
-                      </a:pPr>
-                      <a:r>
-                        <a:rPr lang="en-US" sz="1150" dirty="0">
-                          <a:solidFill>
-                            <a:srgbClr val="1D1D1F"/>
-                          </a:solidFill>
-                        </a:rPr>
-                        <a:t>Infraestructura, APIs y licencias IA</a:t>
-                      </a:r>
-                      <a:endParaRPr lang="en-US" sz="1150" dirty="0"/>
-                    </a:p>
-                  </a:txBody>
-                  <a:tcPr marL="127000" marR="127000" marT="63500" marB="63500" anchor="ctr">
+                  <a:tcPr marL="101600" marR="101600" marT="50800" marB="50800" anchor="ctr">
                     <a:lnL w="0" cap="flat" cmpd="sng" algn="ctr">
                       <a:noFill/>
                     </a:lnL>
@@ -4373,24 +4561,62 @@
                         <a:buNone/>
                       </a:pPr>
                       <a:r>
-                        <a:rPr lang="en-US" sz="1150" b="1" dirty="0">
+                        <a:rPr lang="en-US" sz="950" dirty="0">
                           <a:solidFill>
-                            <a:srgbClr val="0071E3"/>
+                            <a:srgbClr val="48484A"/>
                           </a:solidFill>
-                          <a:latin typeface="Arial" pitchFamily="34" charset="0"/>
-                          <a:ea typeface="Arial" pitchFamily="34" charset="-122"/>
-                          <a:cs typeface="Arial" pitchFamily="34" charset="-120"/>
                         </a:rPr>
-                        <a:t>$4M–$5M</a:t>
+                        <a:t>Acelerar documentación técnica y pruebas</a:t>
                       </a:r>
-                      <a:endParaRPr lang="en-US" sz="1150" dirty="0">
-                        <a:latin typeface="Arial" charset="0"/>
-                        <a:ea typeface="Arial" charset="0"/>
-                        <a:cs typeface="Arial" charset="0"/>
-                      </a:endParaRPr>
+                      <a:endParaRPr lang="en-US" sz="950" dirty="0"/>
                     </a:p>
                   </a:txBody>
-                  <a:tcPr marL="127000" marR="127000" marT="63500" marB="63500" anchor="ctr">
+                  <a:tcPr marL="101600" marR="101600" marT="50800" marB="50800" anchor="ctr">
+                    <a:lnL w="0" cap="flat" cmpd="sng" algn="ctr">
+                      <a:noFill/>
+                    </a:lnL>
+                    <a:lnR w="0" cap="flat" cmpd="sng" algn="ctr">
+                      <a:noFill/>
+                    </a:lnR>
+                    <a:lnT w="0" cap="flat" cmpd="sng" algn="ctr">
+                      <a:noFill/>
+                    </a:lnT>
+                    <a:lnB w="9525" cap="flat" cmpd="sng" algn="ctr">
+                      <a:solidFill>
+                        <a:srgbClr val="E2E2E6"/>
+                      </a:solidFill>
+                      <a:prstDash val="solid"/>
+                      <a:round/>
+                      <a:headEnd type="none" w="med" len="med"/>
+                      <a:tailEnd type="none" w="med" len="med"/>
+                    </a:lnB>
+                    <a:solidFill>
+                      <a:srgbClr val="FFFFFF"/>
+                    </a:solidFill>
+                  </a:tcPr>
+                </a:tc>
+              </a:tr>
+              <a:tr h="333756">
+                <a:tc>
+                  <a:txBody>
+                    <a:bodyPr/>
+                    <a:lstStyle/>
+                    <a:p>
+                      <a:pPr indent="0" marL="0">
+                        <a:buNone/>
+                      </a:pPr>
+                      <a:r>
+                        <a:rPr lang="en-US" sz="950" dirty="0">
+                          <a:solidFill>
+                            <a:srgbClr val="1D1D1F"/>
+                          </a:solidFill>
+                        </a:rPr>
+                        <a:t>Créditos de API de IA para pruebas del PMV</a:t>
+                      </a:r>
+                      <a:endParaRPr lang="en-US" sz="950" dirty="0"/>
+                    </a:p>
+                  </a:txBody>
+                  <a:tcPr marL="101600" marR="101600" marT="50800" marB="50800" anchor="ctr">
                     <a:lnL w="0" cap="flat" cmpd="sng" algn="ctr">
                       <a:noFill/>
                     </a:lnL>
@@ -4423,62 +4649,24 @@
                         <a:buNone/>
                       </a:pPr>
                       <a:r>
-                        <a:rPr lang="en-US" sz="1150" dirty="0">
+                        <a:rPr lang="en-US" sz="950" b="1" dirty="0">
                           <a:solidFill>
-                            <a:srgbClr val="48484A"/>
+                            <a:srgbClr val="0071E3"/>
                           </a:solidFill>
+                          <a:latin typeface="Arial" pitchFamily="34" charset="0"/>
+                          <a:ea typeface="Arial" pitchFamily="34" charset="-122"/>
+                          <a:cs typeface="Arial" pitchFamily="34" charset="-120"/>
                         </a:rPr>
-                        <a:t>Mejorar estabilidad y precisión</a:t>
+                        <a:t>$600.000</a:t>
                       </a:r>
-                      <a:endParaRPr lang="en-US" sz="1150" dirty="0"/>
+                      <a:endParaRPr lang="en-US" sz="950" dirty="0">
+                        <a:latin typeface="Arial" charset="0"/>
+                        <a:ea typeface="Arial" charset="0"/>
+                        <a:cs typeface="Arial" charset="0"/>
+                      </a:endParaRPr>
                     </a:p>
                   </a:txBody>
-                  <a:tcPr marL="127000" marR="127000" marT="63500" marB="63500" anchor="ctr">
-                    <a:lnL w="0" cap="flat" cmpd="sng" algn="ctr">
-                      <a:noFill/>
-                    </a:lnL>
-                    <a:lnR w="0" cap="flat" cmpd="sng" algn="ctr">
-                      <a:noFill/>
-                    </a:lnR>
-                    <a:lnT w="0" cap="flat" cmpd="sng" algn="ctr">
-                      <a:noFill/>
-                    </a:lnT>
-                    <a:lnB w="9525" cap="flat" cmpd="sng" algn="ctr">
-                      <a:solidFill>
-                        <a:srgbClr val="E2E2E6"/>
-                      </a:solidFill>
-                      <a:prstDash val="solid"/>
-                      <a:round/>
-                      <a:headEnd type="none" w="med" len="med"/>
-                      <a:tailEnd type="none" w="med" len="med"/>
-                    </a:lnB>
-                    <a:solidFill>
-                      <a:srgbClr val="FFFFFF"/>
-                    </a:solidFill>
-                  </a:tcPr>
-                </a:tc>
-              </a:tr>
-              <a:tr h="384048">
-                <a:tc>
-                  <a:txBody>
-                    <a:bodyPr/>
-                    <a:lstStyle/>
-                    <a:p>
-                      <a:pPr indent="0" marL="0">
-                        <a:buNone/>
-                      </a:pPr>
-                      <a:r>
-                        <a:rPr lang="en-US" sz="1150" dirty="0">
-                          <a:solidFill>
-                            <a:srgbClr val="1D1D1F"/>
-                          </a:solidFill>
-                        </a:rPr>
-                        <a:t>Desarrollo técnico puntual</a:t>
-                      </a:r>
-                      <a:endParaRPr lang="en-US" sz="1150" dirty="0"/>
-                    </a:p>
-                  </a:txBody>
-                  <a:tcPr marL="127000" marR="127000" marT="63500" marB="63500" anchor="ctr">
+                  <a:tcPr marL="101600" marR="101600" marT="50800" marB="50800" anchor="ctr">
                     <a:lnL w="0" cap="flat" cmpd="sng" algn="ctr">
                       <a:noFill/>
                     </a:lnL>
@@ -4511,24 +4699,62 @@
                         <a:buNone/>
                       </a:pPr>
                       <a:r>
-                        <a:rPr lang="en-US" sz="1150" b="1" dirty="0">
+                        <a:rPr lang="en-US" sz="950" dirty="0">
                           <a:solidFill>
-                            <a:srgbClr val="0071E3"/>
+                            <a:srgbClr val="48484A"/>
                           </a:solidFill>
-                          <a:latin typeface="Arial" pitchFamily="34" charset="0"/>
-                          <a:ea typeface="Arial" pitchFamily="34" charset="-122"/>
-                          <a:cs typeface="Arial" pitchFamily="34" charset="-120"/>
                         </a:rPr>
-                        <a:t>$4M–$5M</a:t>
+                        <a:t>Validar precisión del flujo voz → IA → nota clínica</a:t>
                       </a:r>
-                      <a:endParaRPr lang="en-US" sz="1150" dirty="0">
-                        <a:latin typeface="Arial" charset="0"/>
-                        <a:ea typeface="Arial" charset="0"/>
-                        <a:cs typeface="Arial" charset="0"/>
-                      </a:endParaRPr>
+                      <a:endParaRPr lang="en-US" sz="950" dirty="0"/>
                     </a:p>
                   </a:txBody>
-                  <a:tcPr marL="127000" marR="127000" marT="63500" marB="63500" anchor="ctr">
+                  <a:tcPr marL="101600" marR="101600" marT="50800" marB="50800" anchor="ctr">
+                    <a:lnL w="0" cap="flat" cmpd="sng" algn="ctr">
+                      <a:noFill/>
+                    </a:lnL>
+                    <a:lnR w="0" cap="flat" cmpd="sng" algn="ctr">
+                      <a:noFill/>
+                    </a:lnR>
+                    <a:lnT w="0" cap="flat" cmpd="sng" algn="ctr">
+                      <a:noFill/>
+                    </a:lnT>
+                    <a:lnB w="9525" cap="flat" cmpd="sng" algn="ctr">
+                      <a:solidFill>
+                        <a:srgbClr val="E2E2E6"/>
+                      </a:solidFill>
+                      <a:prstDash val="solid"/>
+                      <a:round/>
+                      <a:headEnd type="none" w="med" len="med"/>
+                      <a:tailEnd type="none" w="med" len="med"/>
+                    </a:lnB>
+                    <a:solidFill>
+                      <a:srgbClr val="FFFFFF"/>
+                    </a:solidFill>
+                  </a:tcPr>
+                </a:tc>
+              </a:tr>
+              <a:tr h="333756">
+                <a:tc>
+                  <a:txBody>
+                    <a:bodyPr/>
+                    <a:lstStyle/>
+                    <a:p>
+                      <a:pPr indent="0" marL="0">
+                        <a:buNone/>
+                      </a:pPr>
+                      <a:r>
+                        <a:rPr lang="en-US" sz="950" dirty="0">
+                          <a:solidFill>
+                            <a:srgbClr val="1D1D1F"/>
+                          </a:solidFill>
+                        </a:rPr>
+                        <a:t>14 dispositivos de captura de audio (tipo Omi)</a:t>
+                      </a:r>
+                      <a:endParaRPr lang="en-US" sz="950" dirty="0"/>
+                    </a:p>
+                  </a:txBody>
+                  <a:tcPr marL="101600" marR="101600" marT="50800" marB="50800" anchor="ctr">
                     <a:lnL w="0" cap="flat" cmpd="sng" algn="ctr">
                       <a:noFill/>
                     </a:lnL>
@@ -4561,62 +4787,24 @@
                         <a:buNone/>
                       </a:pPr>
                       <a:r>
-                        <a:rPr lang="en-US" sz="1150" dirty="0">
+                        <a:rPr lang="en-US" sz="950" b="1" dirty="0">
                           <a:solidFill>
-                            <a:srgbClr val="48484A"/>
+                            <a:srgbClr val="0071E3"/>
                           </a:solidFill>
+                          <a:latin typeface="Arial" pitchFamily="34" charset="0"/>
+                          <a:ea typeface="Arial" pitchFamily="34" charset="-122"/>
+                          <a:cs typeface="Arial" pitchFamily="34" charset="-120"/>
                         </a:rPr>
-                        <a:t>Robustecer la versión piloto</a:t>
+                        <a:t>$5.000.000</a:t>
                       </a:r>
-                      <a:endParaRPr lang="en-US" sz="1150" dirty="0"/>
+                      <a:endParaRPr lang="en-US" sz="950" dirty="0">
+                        <a:latin typeface="Arial" charset="0"/>
+                        <a:ea typeface="Arial" charset="0"/>
+                        <a:cs typeface="Arial" charset="0"/>
+                      </a:endParaRPr>
                     </a:p>
                   </a:txBody>
-                  <a:tcPr marL="127000" marR="127000" marT="63500" marB="63500" anchor="ctr">
-                    <a:lnL w="0" cap="flat" cmpd="sng" algn="ctr">
-                      <a:noFill/>
-                    </a:lnL>
-                    <a:lnR w="0" cap="flat" cmpd="sng" algn="ctr">
-                      <a:noFill/>
-                    </a:lnR>
-                    <a:lnT w="0" cap="flat" cmpd="sng" algn="ctr">
-                      <a:noFill/>
-                    </a:lnT>
-                    <a:lnB w="9525" cap="flat" cmpd="sng" algn="ctr">
-                      <a:solidFill>
-                        <a:srgbClr val="E2E2E6"/>
-                      </a:solidFill>
-                      <a:prstDash val="solid"/>
-                      <a:round/>
-                      <a:headEnd type="none" w="med" len="med"/>
-                      <a:tailEnd type="none" w="med" len="med"/>
-                    </a:lnB>
-                    <a:solidFill>
-                      <a:srgbClr val="FFFFFF"/>
-                    </a:solidFill>
-                  </a:tcPr>
-                </a:tc>
-              </a:tr>
-              <a:tr h="384048">
-                <a:tc>
-                  <a:txBody>
-                    <a:bodyPr/>
-                    <a:lstStyle/>
-                    <a:p>
-                      <a:pPr indent="0" marL="0">
-                        <a:buNone/>
-                      </a:pPr>
-                      <a:r>
-                        <a:rPr lang="en-US" sz="1150" dirty="0">
-                          <a:solidFill>
-                            <a:srgbClr val="1D1D1F"/>
-                          </a:solidFill>
-                        </a:rPr>
-                        <a:t>Pruebas técnicas y seguridad</a:t>
-                      </a:r>
-                      <a:endParaRPr lang="en-US" sz="1150" dirty="0"/>
-                    </a:p>
-                  </a:txBody>
-                  <a:tcPr marL="127000" marR="127000" marT="63500" marB="63500" anchor="ctr">
+                  <a:tcPr marL="101600" marR="101600" marT="50800" marB="50800" anchor="ctr">
                     <a:lnL w="0" cap="flat" cmpd="sng" algn="ctr">
                       <a:noFill/>
                     </a:lnL>
@@ -4649,24 +4837,62 @@
                         <a:buNone/>
                       </a:pPr>
                       <a:r>
-                        <a:rPr lang="en-US" sz="1150" b="1" dirty="0">
+                        <a:rPr lang="en-US" sz="950" dirty="0">
                           <a:solidFill>
-                            <a:srgbClr val="0071E3"/>
+                            <a:srgbClr val="48484A"/>
                           </a:solidFill>
-                          <a:latin typeface="Arial" pitchFamily="34" charset="0"/>
-                          <a:ea typeface="Arial" pitchFamily="34" charset="-122"/>
-                          <a:cs typeface="Arial" pitchFamily="34" charset="-120"/>
                         </a:rPr>
-                        <a:t>$2M–$3M</a:t>
+                        <a:t>Validar calidad de voz en escenarios reales</a:t>
                       </a:r>
-                      <a:endParaRPr lang="en-US" sz="1150" dirty="0">
-                        <a:latin typeface="Arial" charset="0"/>
-                        <a:ea typeface="Arial" charset="0"/>
-                        <a:cs typeface="Arial" charset="0"/>
-                      </a:endParaRPr>
+                      <a:endParaRPr lang="en-US" sz="950" dirty="0"/>
                     </a:p>
                   </a:txBody>
-                  <a:tcPr marL="127000" marR="127000" marT="63500" marB="63500" anchor="ctr">
+                  <a:tcPr marL="101600" marR="101600" marT="50800" marB="50800" anchor="ctr">
+                    <a:lnL w="0" cap="flat" cmpd="sng" algn="ctr">
+                      <a:noFill/>
+                    </a:lnL>
+                    <a:lnR w="0" cap="flat" cmpd="sng" algn="ctr">
+                      <a:noFill/>
+                    </a:lnR>
+                    <a:lnT w="0" cap="flat" cmpd="sng" algn="ctr">
+                      <a:noFill/>
+                    </a:lnT>
+                    <a:lnB w="9525" cap="flat" cmpd="sng" algn="ctr">
+                      <a:solidFill>
+                        <a:srgbClr val="E2E2E6"/>
+                      </a:solidFill>
+                      <a:prstDash val="solid"/>
+                      <a:round/>
+                      <a:headEnd type="none" w="med" len="med"/>
+                      <a:tailEnd type="none" w="med" len="med"/>
+                    </a:lnB>
+                    <a:solidFill>
+                      <a:srgbClr val="FFFFFF"/>
+                    </a:solidFill>
+                  </a:tcPr>
+                </a:tc>
+              </a:tr>
+              <a:tr h="333756">
+                <a:tc>
+                  <a:txBody>
+                    <a:bodyPr/>
+                    <a:lstStyle/>
+                    <a:p>
+                      <a:pPr indent="0" marL="0">
+                        <a:buNone/>
+                      </a:pPr>
+                      <a:r>
+                        <a:rPr lang="en-US" sz="950" dirty="0">
+                          <a:solidFill>
+                            <a:srgbClr val="1D1D1F"/>
+                          </a:solidFill>
+                        </a:rPr>
+                        <a:t>Marketing, branding y producción audiovisual</a:t>
+                      </a:r>
+                      <a:endParaRPr lang="en-US" sz="950" dirty="0"/>
+                    </a:p>
+                  </a:txBody>
+                  <a:tcPr marL="101600" marR="101600" marT="50800" marB="50800" anchor="ctr">
                     <a:lnL w="0" cap="flat" cmpd="sng" algn="ctr">
                       <a:noFill/>
                     </a:lnL>
@@ -4699,62 +4925,24 @@
                         <a:buNone/>
                       </a:pPr>
                       <a:r>
-                        <a:rPr lang="en-US" sz="1150" dirty="0">
+                        <a:rPr lang="en-US" sz="950" b="1" dirty="0">
                           <a:solidFill>
-                            <a:srgbClr val="48484A"/>
+                            <a:srgbClr val="0071E3"/>
                           </a:solidFill>
+                          <a:latin typeface="Arial" pitchFamily="34" charset="0"/>
+                          <a:ea typeface="Arial" pitchFamily="34" charset="-122"/>
+                          <a:cs typeface="Arial" pitchFamily="34" charset="-120"/>
                         </a:rPr>
-                        <a:t>Preparar validación en entorno médico</a:t>
+                        <a:t>$4.000.000</a:t>
                       </a:r>
-                      <a:endParaRPr lang="en-US" sz="1150" dirty="0"/>
+                      <a:endParaRPr lang="en-US" sz="950" dirty="0">
+                        <a:latin typeface="Arial" charset="0"/>
+                        <a:ea typeface="Arial" charset="0"/>
+                        <a:cs typeface="Arial" charset="0"/>
+                      </a:endParaRPr>
                     </a:p>
                   </a:txBody>
-                  <a:tcPr marL="127000" marR="127000" marT="63500" marB="63500" anchor="ctr">
-                    <a:lnL w="0" cap="flat" cmpd="sng" algn="ctr">
-                      <a:noFill/>
-                    </a:lnL>
-                    <a:lnR w="0" cap="flat" cmpd="sng" algn="ctr">
-                      <a:noFill/>
-                    </a:lnR>
-                    <a:lnT w="0" cap="flat" cmpd="sng" algn="ctr">
-                      <a:noFill/>
-                    </a:lnT>
-                    <a:lnB w="9525" cap="flat" cmpd="sng" algn="ctr">
-                      <a:solidFill>
-                        <a:srgbClr val="E2E2E6"/>
-                      </a:solidFill>
-                      <a:prstDash val="solid"/>
-                      <a:round/>
-                      <a:headEnd type="none" w="med" len="med"/>
-                      <a:tailEnd type="none" w="med" len="med"/>
-                    </a:lnB>
-                    <a:solidFill>
-                      <a:srgbClr val="FFFFFF"/>
-                    </a:solidFill>
-                  </a:tcPr>
-                </a:tc>
-              </a:tr>
-              <a:tr h="384048">
-                <a:tc>
-                  <a:txBody>
-                    <a:bodyPr/>
-                    <a:lstStyle/>
-                    <a:p>
-                      <a:pPr indent="0" marL="0">
-                        <a:buNone/>
-                      </a:pPr>
-                      <a:r>
-                        <a:rPr lang="en-US" sz="1150" dirty="0">
-                          <a:solidFill>
-                            <a:srgbClr val="1D1D1F"/>
-                          </a:solidFill>
-                        </a:rPr>
-                        <a:t>Captura de audio / hardware asociado</a:t>
-                      </a:r>
-                      <a:endParaRPr lang="en-US" sz="1150" dirty="0"/>
-                    </a:p>
-                  </a:txBody>
-                  <a:tcPr marL="127000" marR="127000" marT="63500" marB="63500" anchor="ctr">
+                  <a:tcPr marL="101600" marR="101600" marT="50800" marB="50800" anchor="ctr">
                     <a:lnL w="0" cap="flat" cmpd="sng" algn="ctr">
                       <a:noFill/>
                     </a:lnL>
@@ -4787,24 +4975,62 @@
                         <a:buNone/>
                       </a:pPr>
                       <a:r>
-                        <a:rPr lang="en-US" sz="1150" b="1" dirty="0">
+                        <a:rPr lang="en-US" sz="950" dirty="0">
                           <a:solidFill>
-                            <a:srgbClr val="0071E3"/>
+                            <a:srgbClr val="48484A"/>
                           </a:solidFill>
-                          <a:latin typeface="Arial" pitchFamily="34" charset="0"/>
-                          <a:ea typeface="Arial" pitchFamily="34" charset="-122"/>
-                          <a:cs typeface="Arial" pitchFamily="34" charset="-120"/>
                         </a:rPr>
-                        <a:t>$2M</a:t>
+                        <a:t>Video demo y piezas para validar con médicos y clínicas</a:t>
                       </a:r>
-                      <a:endParaRPr lang="en-US" sz="1150" dirty="0">
-                        <a:latin typeface="Arial" charset="0"/>
-                        <a:ea typeface="Arial" charset="0"/>
-                        <a:cs typeface="Arial" charset="0"/>
-                      </a:endParaRPr>
+                      <a:endParaRPr lang="en-US" sz="950" dirty="0"/>
                     </a:p>
                   </a:txBody>
-                  <a:tcPr marL="127000" marR="127000" marT="63500" marB="63500" anchor="ctr">
+                  <a:tcPr marL="101600" marR="101600" marT="50800" marB="50800" anchor="ctr">
+                    <a:lnL w="0" cap="flat" cmpd="sng" algn="ctr">
+                      <a:noFill/>
+                    </a:lnL>
+                    <a:lnR w="0" cap="flat" cmpd="sng" algn="ctr">
+                      <a:noFill/>
+                    </a:lnR>
+                    <a:lnT w="0" cap="flat" cmpd="sng" algn="ctr">
+                      <a:noFill/>
+                    </a:lnT>
+                    <a:lnB w="9525" cap="flat" cmpd="sng" algn="ctr">
+                      <a:solidFill>
+                        <a:srgbClr val="E2E2E6"/>
+                      </a:solidFill>
+                      <a:prstDash val="solid"/>
+                      <a:round/>
+                      <a:headEnd type="none" w="med" len="med"/>
+                      <a:tailEnd type="none" w="med" len="med"/>
+                    </a:lnB>
+                    <a:solidFill>
+                      <a:srgbClr val="FFFFFF"/>
+                    </a:solidFill>
+                  </a:tcPr>
+                </a:tc>
+              </a:tr>
+              <a:tr h="333756">
+                <a:tc>
+                  <a:txBody>
+                    <a:bodyPr/>
+                    <a:lstStyle/>
+                    <a:p>
+                      <a:pPr indent="0" marL="0">
+                        <a:buNone/>
+                      </a:pPr>
+                      <a:r>
+                        <a:rPr lang="en-US" sz="950" dirty="0">
+                          <a:solidFill>
+                            <a:srgbClr val="1D1D1F"/>
+                          </a:solidFill>
+                        </a:rPr>
+                        <a:t>Registro y protección de la marca Miracle</a:t>
+                      </a:r>
+                      <a:endParaRPr lang="en-US" sz="950" dirty="0"/>
+                    </a:p>
+                  </a:txBody>
+                  <a:tcPr marL="101600" marR="101600" marT="50800" marB="50800" anchor="ctr">
                     <a:lnL w="0" cap="flat" cmpd="sng" algn="ctr">
                       <a:noFill/>
                     </a:lnL>
@@ -4837,62 +5063,24 @@
                         <a:buNone/>
                       </a:pPr>
                       <a:r>
-                        <a:rPr lang="en-US" sz="1150" dirty="0">
+                        <a:rPr lang="en-US" sz="950" b="1" dirty="0">
                           <a:solidFill>
-                            <a:srgbClr val="48484A"/>
+                            <a:srgbClr val="0071E3"/>
                           </a:solidFill>
+                          <a:latin typeface="Arial" pitchFamily="34" charset="0"/>
+                          <a:ea typeface="Arial" pitchFamily="34" charset="-122"/>
+                          <a:cs typeface="Arial" pitchFamily="34" charset="-120"/>
                         </a:rPr>
-                        <a:t>Mejorar calidad de entrada de audio</a:t>
+                        <a:t>$1.000.000</a:t>
                       </a:r>
-                      <a:endParaRPr lang="en-US" sz="1150" dirty="0"/>
+                      <a:endParaRPr lang="en-US" sz="950" dirty="0">
+                        <a:latin typeface="Arial" charset="0"/>
+                        <a:ea typeface="Arial" charset="0"/>
+                        <a:cs typeface="Arial" charset="0"/>
+                      </a:endParaRPr>
                     </a:p>
                   </a:txBody>
-                  <a:tcPr marL="127000" marR="127000" marT="63500" marB="63500" anchor="ctr">
-                    <a:lnL w="0" cap="flat" cmpd="sng" algn="ctr">
-                      <a:noFill/>
-                    </a:lnL>
-                    <a:lnR w="0" cap="flat" cmpd="sng" algn="ctr">
-                      <a:noFill/>
-                    </a:lnR>
-                    <a:lnT w="0" cap="flat" cmpd="sng" algn="ctr">
-                      <a:noFill/>
-                    </a:lnT>
-                    <a:lnB w="9525" cap="flat" cmpd="sng" algn="ctr">
-                      <a:solidFill>
-                        <a:srgbClr val="E2E2E6"/>
-                      </a:solidFill>
-                      <a:prstDash val="solid"/>
-                      <a:round/>
-                      <a:headEnd type="none" w="med" len="med"/>
-                      <a:tailEnd type="none" w="med" len="med"/>
-                    </a:lnB>
-                    <a:solidFill>
-                      <a:srgbClr val="FFFFFF"/>
-                    </a:solidFill>
-                  </a:tcPr>
-                </a:tc>
-              </a:tr>
-              <a:tr h="384048">
-                <a:tc>
-                  <a:txBody>
-                    <a:bodyPr/>
-                    <a:lstStyle/>
-                    <a:p>
-                      <a:pPr indent="0" marL="0">
-                        <a:buNone/>
-                      </a:pPr>
-                      <a:r>
-                        <a:rPr lang="en-US" sz="1150" dirty="0">
-                          <a:solidFill>
-                            <a:srgbClr val="1D1D1F"/>
-                          </a:solidFill>
-                        </a:rPr>
-                        <a:t>Material comercial y demo</a:t>
-                      </a:r>
-                      <a:endParaRPr lang="en-US" sz="1150" dirty="0"/>
-                    </a:p>
-                  </a:txBody>
-                  <a:tcPr marL="127000" marR="127000" marT="63500" marB="63500" anchor="ctr">
+                  <a:tcPr marL="101600" marR="101600" marT="50800" marB="50800" anchor="ctr">
                     <a:lnL w="0" cap="flat" cmpd="sng" algn="ctr">
                       <a:noFill/>
                     </a:lnL>
@@ -4925,24 +5113,62 @@
                         <a:buNone/>
                       </a:pPr>
                       <a:r>
-                        <a:rPr lang="en-US" sz="1150" b="1" dirty="0">
+                        <a:rPr lang="en-US" sz="950" dirty="0">
                           <a:solidFill>
-                            <a:srgbClr val="0071E3"/>
+                            <a:srgbClr val="48484A"/>
                           </a:solidFill>
-                          <a:latin typeface="Arial" pitchFamily="34" charset="0"/>
-                          <a:ea typeface="Arial" pitchFamily="34" charset="-122"/>
-                          <a:cs typeface="Arial" pitchFamily="34" charset="-120"/>
                         </a:rPr>
-                        <a:t>Hasta $3M</a:t>
+                        <a:t>Proteger el nombre y los activos intangibles</a:t>
                       </a:r>
-                      <a:endParaRPr lang="en-US" sz="1150" dirty="0">
-                        <a:latin typeface="Arial" charset="0"/>
-                        <a:ea typeface="Arial" charset="0"/>
-                        <a:cs typeface="Arial" charset="0"/>
-                      </a:endParaRPr>
+                      <a:endParaRPr lang="en-US" sz="950" dirty="0"/>
                     </a:p>
                   </a:txBody>
-                  <a:tcPr marL="127000" marR="127000" marT="63500" marB="63500" anchor="ctr">
+                  <a:tcPr marL="101600" marR="101600" marT="50800" marB="50800" anchor="ctr">
+                    <a:lnL w="0" cap="flat" cmpd="sng" algn="ctr">
+                      <a:noFill/>
+                    </a:lnL>
+                    <a:lnR w="0" cap="flat" cmpd="sng" algn="ctr">
+                      <a:noFill/>
+                    </a:lnR>
+                    <a:lnT w="0" cap="flat" cmpd="sng" algn="ctr">
+                      <a:noFill/>
+                    </a:lnT>
+                    <a:lnB w="9525" cap="flat" cmpd="sng" algn="ctr">
+                      <a:solidFill>
+                        <a:srgbClr val="E2E2E6"/>
+                      </a:solidFill>
+                      <a:prstDash val="solid"/>
+                      <a:round/>
+                      <a:headEnd type="none" w="med" len="med"/>
+                      <a:tailEnd type="none" w="med" len="med"/>
+                    </a:lnB>
+                    <a:solidFill>
+                      <a:srgbClr val="FFFFFF"/>
+                    </a:solidFill>
+                  </a:tcPr>
+                </a:tc>
+              </a:tr>
+              <a:tr h="333756">
+                <a:tc>
+                  <a:txBody>
+                    <a:bodyPr/>
+                    <a:lstStyle/>
+                    <a:p>
+                      <a:pPr indent="0" marL="0">
+                        <a:buNone/>
+                      </a:pPr>
+                      <a:r>
+                        <a:rPr lang="en-US" sz="1050" b="1" dirty="0">
+                          <a:solidFill>
+                            <a:srgbClr val="1D1D1F"/>
+                          </a:solidFill>
+                        </a:rPr>
+                        <a:t>Total</a:t>
+                      </a:r>
+                      <a:endParaRPr lang="en-US" sz="1050" dirty="0"/>
+                    </a:p>
+                  </a:txBody>
+                  <a:tcPr marL="101600" marR="101600" marT="50800" marB="50800" anchor="ctr">
                     <a:lnL w="0" cap="flat" cmpd="sng" algn="ctr">
                       <a:noFill/>
                     </a:lnL>
@@ -4975,17 +5201,59 @@
                         <a:buNone/>
                       </a:pPr>
                       <a:r>
-                        <a:rPr lang="en-US" sz="1150" dirty="0">
+                        <a:rPr lang="en-US" sz="1050" b="1" dirty="0">
                           <a:solidFill>
-                            <a:srgbClr val="48484A"/>
+                            <a:srgbClr val="0A3D91"/>
                           </a:solidFill>
+                          <a:latin typeface="Arial" pitchFamily="34" charset="0"/>
+                          <a:ea typeface="Arial" pitchFamily="34" charset="-122"/>
+                          <a:cs typeface="Arial" pitchFamily="34" charset="-120"/>
                         </a:rPr>
-                        <a:t>Conseguir pilotos y validación comercial</a:t>
+                        <a:t>$15.000.000</a:t>
                       </a:r>
-                      <a:endParaRPr lang="en-US" sz="1150" dirty="0"/>
+                      <a:endParaRPr lang="en-US" sz="1050" dirty="0">
+                        <a:latin typeface="Arial" charset="0"/>
+                        <a:ea typeface="Arial" charset="0"/>
+                        <a:cs typeface="Arial" charset="0"/>
+                      </a:endParaRPr>
                     </a:p>
                   </a:txBody>
-                  <a:tcPr marL="127000" marR="127000" marT="63500" marB="63500" anchor="ctr">
+                  <a:tcPr marL="101600" marR="101600" marT="50800" marB="50800" anchor="ctr">
+                    <a:lnL w="0" cap="flat" cmpd="sng" algn="ctr">
+                      <a:noFill/>
+                    </a:lnL>
+                    <a:lnR w="0" cap="flat" cmpd="sng" algn="ctr">
+                      <a:noFill/>
+                    </a:lnR>
+                    <a:lnT w="0" cap="flat" cmpd="sng" algn="ctr">
+                      <a:noFill/>
+                    </a:lnT>
+                    <a:lnB w="9525" cap="flat" cmpd="sng" algn="ctr">
+                      <a:solidFill>
+                        <a:srgbClr val="E2E2E6"/>
+                      </a:solidFill>
+                      <a:prstDash val="solid"/>
+                      <a:round/>
+                      <a:headEnd type="none" w="med" len="med"/>
+                      <a:tailEnd type="none" w="med" len="med"/>
+                    </a:lnB>
+                    <a:solidFill>
+                      <a:srgbClr val="FFFFFF"/>
+                    </a:solidFill>
+                  </a:tcPr>
+                </a:tc>
+                <a:tc>
+                  <a:txBody>
+                    <a:bodyPr/>
+                    <a:lstStyle/>
+                    <a:p>
+                      <a:pPr indent="0" marL="0">
+                        <a:buNone/>
+                      </a:pPr>
+                      <a:endParaRPr lang="en-US" sz="1200" dirty="0"/>
+                    </a:p>
+                  </a:txBody>
+                  <a:tcPr marL="101600" marR="101600" marT="50800" marB="50800" anchor="ctr">
                     <a:lnL w="0" cap="flat" cmpd="sng" algn="ctr">
                       <a:noFill/>
                     </a:lnL>
@@ -5022,8 +5290,8 @@
         </p:nvSpPr>
         <p:spPr>
           <a:xfrm>
-            <a:off x="502920" y="4526280"/>
-            <a:ext cx="8138160" cy="457200"/>
+            <a:off x="502920" y="4370832"/>
+            <a:ext cx="8138160" cy="347472"/>
           </a:xfrm>
           <a:prstGeom prst="rect">
             <a:avLst/>
@@ -5039,7 +5307,7 @@
               <a:buNone/>
             </a:pPr>
             <a:r>
-              <a:rPr lang="en-US" sz="1250" b="1" i="1" dirty="0">
+              <a:rPr lang="en-US" sz="1100" b="1" i="1" dirty="0">
                 <a:solidFill>
                   <a:srgbClr val="0A3D91"/>
                 </a:solidFill>
@@ -5049,7 +5317,46 @@
               </a:rPr>
               <a:t>El incentivo no es para iniciar desde cero; es para acelerar una solución que ya está en desarrollo.</a:t>
             </a:r>
-            <a:endParaRPr lang="en-US" sz="1250" dirty="0"/>
+            <a:endParaRPr lang="en-US" sz="1100" dirty="0"/>
+          </a:p>
+        </p:txBody>
+      </p:sp>
+      <p:sp>
+        <p:nvSpPr>
+          <p:cNvPr id="6" name="Text 3"/>
+          <p:cNvSpPr/>
+          <p:nvPr/>
+        </p:nvSpPr>
+        <p:spPr>
+          <a:xfrm>
+            <a:off x="502920" y="4736592"/>
+            <a:ext cx="8138160" cy="274320"/>
+          </a:xfrm>
+          <a:prstGeom prst="rect">
+            <a:avLst/>
+          </a:prstGeom>
+          <a:noFill/>
+          <a:ln/>
+        </p:spPr>
+        <p:txBody>
+          <a:bodyPr wrap="square" lIns="0" tIns="0" rIns="0" bIns="0" rtlCol="0" anchor="ctr"/>
+          <a:lstStyle/>
+          <a:p>
+            <a:pPr indent="0" marL="0">
+              <a:buNone/>
+            </a:pPr>
+            <a:r>
+              <a:rPr lang="en-US" sz="750" dirty="0">
+                <a:solidFill>
+                  <a:srgbClr val="6E6E73"/>
+                </a:solidFill>
+                <a:latin typeface="Arial" pitchFamily="34" charset="0"/>
+                <a:ea typeface="Arial" pitchFamily="34" charset="-122"/>
+                <a:cs typeface="Arial" pitchFamily="34" charset="-120"/>
+              </a:rPr>
+              <a:t>Cifras del Plan de Inversión aprobado — Contrato interadministrativo #4600107420 de 2026.</a:t>
+            </a:r>
+            <a:endParaRPr lang="en-US" sz="750" dirty="0"/>
           </a:p>
         </p:txBody>
       </p:sp>

</xml_diff>

<commit_message>
Fill in real team names and roles for slide 11
José David Jaramillo Cortés (CTO), Christian Felipe Maldonado Ortiz (CEO),
Juan Pablo Arteaga (CCO), Isabel Sofía García (CFO).
</commit_message>
<xml_diff>
--- a/miracle_capital_semilla_pitch.pptx
+++ b/miracle_capital_semilla_pitch.pptx
@@ -3383,7 +3383,7 @@
                 <a:ea typeface="Arial" pitchFamily="34" charset="-122"/>
                 <a:cs typeface="Arial" pitchFamily="34" charset="-120"/>
               </a:rPr>
-              <a:t>[Nombre]</a:t>
+              <a:t>José David Jaramillo Cortés</a:t>
             </a:r>
             <a:endParaRPr lang="en-US" sz="1300" dirty="0"/>
           </a:p>
@@ -3422,7 +3422,7 @@
                 <a:ea typeface="Arial" pitchFamily="34" charset="-122"/>
                 <a:cs typeface="Arial" pitchFamily="34" charset="-120"/>
               </a:rPr>
-              <a:t>[Rol]</a:t>
+              <a:t>CTO</a:t>
             </a:r>
             <a:endParaRPr lang="en-US" sz="1000" dirty="0"/>
           </a:p>
@@ -3578,7 +3578,7 @@
                 <a:ea typeface="Arial" pitchFamily="34" charset="-122"/>
                 <a:cs typeface="Arial" pitchFamily="34" charset="-120"/>
               </a:rPr>
-              <a:t>[Nombre]</a:t>
+              <a:t>Christian Felipe Maldonado Ortiz</a:t>
             </a:r>
             <a:endParaRPr lang="en-US" sz="1300" dirty="0"/>
           </a:p>
@@ -3617,7 +3617,7 @@
                 <a:ea typeface="Arial" pitchFamily="34" charset="-122"/>
                 <a:cs typeface="Arial" pitchFamily="34" charset="-120"/>
               </a:rPr>
-              <a:t>[Rol]</a:t>
+              <a:t>CEO</a:t>
             </a:r>
             <a:endParaRPr lang="en-US" sz="1000" dirty="0"/>
           </a:p>
@@ -3773,7 +3773,7 @@
                 <a:ea typeface="Arial" pitchFamily="34" charset="-122"/>
                 <a:cs typeface="Arial" pitchFamily="34" charset="-120"/>
               </a:rPr>
-              <a:t>[Nombre]</a:t>
+              <a:t>Juan Pablo Arteaga</a:t>
             </a:r>
             <a:endParaRPr lang="en-US" sz="1300" dirty="0"/>
           </a:p>
@@ -3812,7 +3812,7 @@
                 <a:ea typeface="Arial" pitchFamily="34" charset="-122"/>
                 <a:cs typeface="Arial" pitchFamily="34" charset="-120"/>
               </a:rPr>
-              <a:t>[Rol]</a:t>
+              <a:t>CCO</a:t>
             </a:r>
             <a:endParaRPr lang="en-US" sz="1000" dirty="0"/>
           </a:p>
@@ -3968,7 +3968,7 @@
                 <a:ea typeface="Arial" pitchFamily="34" charset="-122"/>
                 <a:cs typeface="Arial" pitchFamily="34" charset="-120"/>
               </a:rPr>
-              <a:t>[Nombre]</a:t>
+              <a:t>Isabel Sofía García</a:t>
             </a:r>
             <a:endParaRPr lang="en-US" sz="1300" dirty="0"/>
           </a:p>
@@ -4007,7 +4007,7 @@
                 <a:ea typeface="Arial" pitchFamily="34" charset="-122"/>
                 <a:cs typeface="Arial" pitchFamily="34" charset="-120"/>
               </a:rPr>
-              <a:t>[Rol]</a:t>
+              <a:t>CFO</a:t>
             </a:r>
             <a:endParaRPr lang="en-US" sz="1000" dirty="0"/>
           </a:p>

</xml_diff>

<commit_message>
Fix content overlapping the dots/counter chrome and redesign the market slide
Every slide's bottom content was flush (or overflowing) against the fixed
dots/slide-counter — slides 2, 7 and 13 actually collided with it at 720p.
Reserve extra bottom clearance on .slide, shrink/reposition the ECG line so
it never crosses text, and trim spacing on slides 2/5/13.

Replace the TAM/SAM/SOM stacked bars (slide 7) with three horizontal stat
cards — icon, big number, one-line caption — much faster to scan on stage,
with a light→dark tint progression to reinforce the zoom-in narrative.
</commit_message>
<xml_diff>
--- a/miracle_capital_semilla_pitch.pptx
+++ b/miracle_capital_semilla_pitch.pptx
@@ -10964,12 +10964,12 @@
         </p:nvSpPr>
         <p:spPr>
           <a:xfrm>
-            <a:off x="502920" y="1371600"/>
-            <a:ext cx="8138160" cy="960120"/>
+            <a:off x="502920" y="1417320"/>
+            <a:ext cx="2542032" cy="1965960"/>
           </a:xfrm>
           <a:prstGeom prst="roundRect">
             <a:avLst>
-              <a:gd name="adj" fmla="val 8571"/>
+              <a:gd name="adj" fmla="val 4186"/>
             </a:avLst>
           </a:prstGeom>
           <a:solidFill>
@@ -10992,14 +10992,58 @@
       </p:sp>
       <p:sp>
         <p:nvSpPr>
-          <p:cNvPr id="5" name="Text 3"/>
-          <p:cNvSpPr/>
-          <p:nvPr/>
-        </p:nvSpPr>
-        <p:spPr>
-          <a:xfrm>
-            <a:off x="731520" y="1463040"/>
-            <a:ext cx="4475988" cy="201168"/>
+          <p:cNvPr id="5" name="Shape 3"/>
+          <p:cNvSpPr/>
+          <p:nvPr/>
+        </p:nvSpPr>
+        <p:spPr>
+          <a:xfrm>
+            <a:off x="1517904" y="1618488"/>
+            <a:ext cx="512064" cy="512064"/>
+          </a:xfrm>
+          <a:prstGeom prst="ellipse">
+            <a:avLst/>
+          </a:prstGeom>
+          <a:solidFill>
+            <a:srgbClr val="FFFFFF"/>
+          </a:solidFill>
+          <a:ln/>
+        </p:spPr>
+      </p:sp>
+      <p:pic>
+        <p:nvPicPr>
+          <p:cNvPr id="6" name="Image 0" descr="preencoded.png">    </p:cNvPr>
+          <p:cNvPicPr>
+            <a:picLocks noChangeAspect="1"/>
+          </p:cNvPicPr>
+          <p:nvPr/>
+        </p:nvPicPr>
+        <p:blipFill>
+          <a:blip r:embed="rId1"/>
+          <a:stretch>
+            <a:fillRect/>
+          </a:stretch>
+        </p:blipFill>
+        <p:spPr>
+          <a:xfrm>
+            <a:off x="1589593" y="1690177"/>
+            <a:ext cx="368686" cy="368686"/>
+          </a:xfrm>
+          <a:prstGeom prst="rect">
+            <a:avLst/>
+          </a:prstGeom>
+        </p:spPr>
+      </p:pic>
+      <p:sp>
+        <p:nvSpPr>
+          <p:cNvPr id="7" name="Text 4"/>
+          <p:cNvSpPr/>
+          <p:nvPr/>
+        </p:nvSpPr>
+        <p:spPr>
+          <a:xfrm>
+            <a:off x="640080" y="2240280"/>
+            <a:ext cx="2267712" cy="219456"/>
           </a:xfrm>
           <a:prstGeom prst="rect">
             <a:avLst/>
@@ -11011,11 +11055,11 @@
           <a:bodyPr wrap="square" lIns="0" tIns="0" rIns="0" bIns="0" rtlCol="0" anchor="ctr"/>
           <a:lstStyle/>
           <a:p>
-            <a:pPr indent="0" marL="0">
-              <a:buNone/>
-            </a:pPr>
-            <a:r>
-              <a:rPr lang="en-US" sz="800" b="1" spc="100" kern="0" dirty="0">
+            <a:pPr algn="ctr" indent="0" marL="0">
+              <a:buNone/>
+            </a:pPr>
+            <a:r>
+              <a:rPr lang="en-US" sz="850" b="1" spc="100" kern="0" dirty="0">
                 <a:solidFill>
                   <a:srgbClr val="0071E3"/>
                 </a:solidFill>
@@ -11023,22 +11067,61 @@
                 <a:ea typeface="Arial" pitchFamily="34" charset="-122"/>
                 <a:cs typeface="Arial" pitchFamily="34" charset="-120"/>
               </a:rPr>
-              <a:t>TAM · LATINOAMÉRICA</a:t>
-            </a:r>
-            <a:endParaRPr lang="en-US" sz="800" dirty="0"/>
-          </a:p>
-        </p:txBody>
-      </p:sp>
-      <p:sp>
-        <p:nvSpPr>
-          <p:cNvPr id="6" name="Text 4"/>
-          <p:cNvSpPr/>
-          <p:nvPr/>
-        </p:nvSpPr>
-        <p:spPr>
-          <a:xfrm>
-            <a:off x="731520" y="1664208"/>
-            <a:ext cx="4475988" cy="347472"/>
+              <a:t>TAM · LATAM</a:t>
+            </a:r>
+            <a:endParaRPr lang="en-US" sz="850" dirty="0"/>
+          </a:p>
+        </p:txBody>
+      </p:sp>
+      <p:sp>
+        <p:nvSpPr>
+          <p:cNvPr id="8" name="Text 5"/>
+          <p:cNvSpPr/>
+          <p:nvPr/>
+        </p:nvSpPr>
+        <p:spPr>
+          <a:xfrm>
+            <a:off x="594360" y="2478024"/>
+            <a:ext cx="2359152" cy="384048"/>
+          </a:xfrm>
+          <a:prstGeom prst="rect">
+            <a:avLst/>
+          </a:prstGeom>
+          <a:noFill/>
+          <a:ln/>
+        </p:spPr>
+        <p:txBody>
+          <a:bodyPr wrap="square" lIns="0" tIns="0" rIns="0" bIns="0" rtlCol="0" anchor="ctr"/>
+          <a:lstStyle/>
+          <a:p>
+            <a:pPr algn="ctr" indent="0" marL="0">
+              <a:buNone/>
+            </a:pPr>
+            <a:r>
+              <a:rPr lang="en-US" sz="1900" b="1" dirty="0">
+                <a:solidFill>
+                  <a:srgbClr val="0A3D91"/>
+                </a:solidFill>
+                <a:latin typeface="Arial" pitchFamily="34" charset="0"/>
+                <a:ea typeface="Arial" pitchFamily="34" charset="-122"/>
+                <a:cs typeface="Arial" pitchFamily="34" charset="-120"/>
+              </a:rPr>
+              <a:t>USD 66.400M</a:t>
+            </a:r>
+            <a:endParaRPr lang="en-US" sz="1900" dirty="0"/>
+          </a:p>
+        </p:txBody>
+      </p:sp>
+      <p:sp>
+        <p:nvSpPr>
+          <p:cNvPr id="9" name="Text 6"/>
+          <p:cNvSpPr/>
+          <p:nvPr/>
+        </p:nvSpPr>
+        <p:spPr>
+          <a:xfrm>
+            <a:off x="667512" y="2880360"/>
+            <a:ext cx="2212848" cy="457200"/>
           </a:xfrm>
           <a:prstGeom prst="rect">
             <a:avLst/>
@@ -11050,116 +11133,38 @@
           <a:bodyPr wrap="square" lIns="0" tIns="0" rIns="0" bIns="0" rtlCol="0" anchor="t"/>
           <a:lstStyle/>
           <a:p>
-            <a:pPr indent="0" marL="0">
-              <a:buNone/>
-            </a:pPr>
-            <a:r>
-              <a:rPr lang="en-US" sz="950" b="1" dirty="0">
-                <a:solidFill>
-                  <a:srgbClr val="1D1D1F"/>
-                </a:solidFill>
-                <a:latin typeface="Arial" pitchFamily="34" charset="0"/>
-                <a:ea typeface="Arial" pitchFamily="34" charset="-122"/>
-                <a:cs typeface="Arial" pitchFamily="34" charset="-120"/>
-              </a:rPr>
-              <a:t>Salud digital en LatAm</a:t>
-            </a:r>
-            <a:endParaRPr lang="en-US" sz="950" dirty="0"/>
-          </a:p>
-        </p:txBody>
-      </p:sp>
-      <p:sp>
-        <p:nvSpPr>
-          <p:cNvPr id="7" name="Text 5"/>
-          <p:cNvSpPr/>
-          <p:nvPr/>
-        </p:nvSpPr>
-        <p:spPr>
-          <a:xfrm>
-            <a:off x="731520" y="2029968"/>
-            <a:ext cx="7680960" cy="256032"/>
-          </a:xfrm>
-          <a:prstGeom prst="rect">
-            <a:avLst/>
-          </a:prstGeom>
-          <a:noFill/>
-          <a:ln/>
-        </p:spPr>
-        <p:txBody>
-          <a:bodyPr wrap="square" lIns="0" tIns="0" rIns="0" bIns="0" rtlCol="0" anchor="ctr"/>
-          <a:lstStyle/>
-          <a:p>
-            <a:pPr indent="0" marL="0">
-              <a:buNone/>
-            </a:pPr>
-            <a:r>
-              <a:rPr lang="en-US" sz="1250" b="1" dirty="0">
-                <a:solidFill>
-                  <a:srgbClr val="0A3D91"/>
-                </a:solidFill>
-                <a:latin typeface="Arial" pitchFamily="34" charset="0"/>
-                <a:ea typeface="Arial" pitchFamily="34" charset="-122"/>
-                <a:cs typeface="Arial" pitchFamily="34" charset="-120"/>
-              </a:rPr>
-              <a:t>USD 12.800M → 66.400M</a:t>
-            </a:r>
-            <a:endParaRPr lang="en-US" sz="1250" dirty="0"/>
-          </a:p>
-        </p:txBody>
-      </p:sp>
-      <p:sp>
-        <p:nvSpPr>
-          <p:cNvPr id="8" name="Text 6"/>
-          <p:cNvSpPr/>
-          <p:nvPr/>
-        </p:nvSpPr>
-        <p:spPr>
-          <a:xfrm>
-            <a:off x="4978908" y="1463040"/>
-            <a:ext cx="3418027" cy="777240"/>
-          </a:xfrm>
-          <a:prstGeom prst="rect">
-            <a:avLst/>
-          </a:prstGeom>
-          <a:noFill/>
-          <a:ln/>
-        </p:spPr>
-        <p:txBody>
-          <a:bodyPr wrap="square" lIns="0" tIns="0" rIns="0" bIns="0" rtlCol="0" anchor="ctr"/>
-          <a:lstStyle/>
-          <a:p>
-            <a:pPr algn="r" indent="0" marL="0">
-              <a:buNone/>
-            </a:pPr>
-            <a:r>
-              <a:rPr lang="en-US" sz="750" dirty="0">
-                <a:solidFill>
-                  <a:srgbClr val="6E6E73"/>
-                </a:solidFill>
-                <a:latin typeface="Arial" pitchFamily="34" charset="0"/>
-                <a:ea typeface="Arial" pitchFamily="34" charset="-122"/>
-                <a:cs typeface="Arial" pitchFamily="34" charset="-120"/>
-              </a:rPr>
-              <a:t>Tamaño 2024 y proyección 2033 · CAGR ≈ 20% anual</a:t>
-            </a:r>
-            <a:endParaRPr lang="en-US" sz="750" dirty="0"/>
-          </a:p>
-        </p:txBody>
-      </p:sp>
-      <p:sp>
-        <p:nvSpPr>
-          <p:cNvPr id="9" name="Shape 7"/>
-          <p:cNvSpPr/>
-          <p:nvPr/>
-        </p:nvSpPr>
-        <p:spPr>
-          <a:xfrm>
-            <a:off x="1398118" y="2459736"/>
-            <a:ext cx="6347765" cy="960120"/>
+            <a:pPr algn="ctr" indent="0" marL="0">
+              <a:buNone/>
+            </a:pPr>
+            <a:r>
+              <a:rPr lang="en-US" sz="900" dirty="0">
+                <a:solidFill>
+                  <a:srgbClr val="48484A"/>
+                </a:solidFill>
+                <a:latin typeface="Arial" pitchFamily="34" charset="0"/>
+                <a:ea typeface="Arial" pitchFamily="34" charset="-122"/>
+                <a:cs typeface="Arial" pitchFamily="34" charset="-120"/>
+              </a:rPr>
+              <a:t>Salud digital en LatAm para 2033 · CAGR ≈20%/año</a:t>
+            </a:r>
+            <a:endParaRPr lang="en-US" sz="900" dirty="0"/>
+          </a:p>
+        </p:txBody>
+      </p:sp>
+      <p:sp>
+        <p:nvSpPr>
+          <p:cNvPr id="10" name="Shape 7"/>
+          <p:cNvSpPr/>
+          <p:nvPr/>
+        </p:nvSpPr>
+        <p:spPr>
+          <a:xfrm>
+            <a:off x="3300984" y="1417320"/>
+            <a:ext cx="2542032" cy="1965960"/>
           </a:xfrm>
           <a:prstGeom prst="roundRect">
             <a:avLst>
-              <a:gd name="adj" fmla="val 8571"/>
+              <a:gd name="adj" fmla="val 4186"/>
             </a:avLst>
           </a:prstGeom>
           <a:solidFill>
@@ -11182,14 +11187,58 @@
       </p:sp>
       <p:sp>
         <p:nvSpPr>
-          <p:cNvPr id="10" name="Text 8"/>
-          <p:cNvSpPr/>
-          <p:nvPr/>
-        </p:nvSpPr>
-        <p:spPr>
-          <a:xfrm>
-            <a:off x="1626718" y="2551176"/>
-            <a:ext cx="3491271" cy="201168"/>
+          <p:cNvPr id="11" name="Shape 8"/>
+          <p:cNvSpPr/>
+          <p:nvPr/>
+        </p:nvSpPr>
+        <p:spPr>
+          <a:xfrm>
+            <a:off x="4315968" y="1618488"/>
+            <a:ext cx="512064" cy="512064"/>
+          </a:xfrm>
+          <a:prstGeom prst="ellipse">
+            <a:avLst/>
+          </a:prstGeom>
+          <a:solidFill>
+            <a:srgbClr val="FFFFFF"/>
+          </a:solidFill>
+          <a:ln/>
+        </p:spPr>
+      </p:sp>
+      <p:pic>
+        <p:nvPicPr>
+          <p:cNvPr id="12" name="Image 1" descr="preencoded.png">    </p:cNvPr>
+          <p:cNvPicPr>
+            <a:picLocks noChangeAspect="1"/>
+          </p:cNvPicPr>
+          <p:nvPr/>
+        </p:nvPicPr>
+        <p:blipFill>
+          <a:blip r:embed="rId2"/>
+          <a:stretch>
+            <a:fillRect/>
+          </a:stretch>
+        </p:blipFill>
+        <p:spPr>
+          <a:xfrm>
+            <a:off x="4387657" y="1690177"/>
+            <a:ext cx="368686" cy="368686"/>
+          </a:xfrm>
+          <a:prstGeom prst="rect">
+            <a:avLst/>
+          </a:prstGeom>
+        </p:spPr>
+      </p:pic>
+      <p:sp>
+        <p:nvSpPr>
+          <p:cNvPr id="13" name="Text 9"/>
+          <p:cNvSpPr/>
+          <p:nvPr/>
+        </p:nvSpPr>
+        <p:spPr>
+          <a:xfrm>
+            <a:off x="3438144" y="2240280"/>
+            <a:ext cx="2267712" cy="219456"/>
           </a:xfrm>
           <a:prstGeom prst="rect">
             <a:avLst/>
@@ -11201,11 +11250,11 @@
           <a:bodyPr wrap="square" lIns="0" tIns="0" rIns="0" bIns="0" rtlCol="0" anchor="ctr"/>
           <a:lstStyle/>
           <a:p>
-            <a:pPr indent="0" marL="0">
-              <a:buNone/>
-            </a:pPr>
-            <a:r>
-              <a:rPr lang="en-US" sz="800" b="1" spc="100" kern="0" dirty="0">
+            <a:pPr algn="ctr" indent="0" marL="0">
+              <a:buNone/>
+            </a:pPr>
+            <a:r>
+              <a:rPr lang="en-US" sz="850" b="1" spc="100" kern="0" dirty="0">
                 <a:solidFill>
                   <a:srgbClr val="0071E3"/>
                 </a:solidFill>
@@ -11215,20 +11264,59 @@
               </a:rPr>
               <a:t>SAM · COLOMBIA</a:t>
             </a:r>
-            <a:endParaRPr lang="en-US" sz="800" dirty="0"/>
-          </a:p>
-        </p:txBody>
-      </p:sp>
-      <p:sp>
-        <p:nvSpPr>
-          <p:cNvPr id="11" name="Text 9"/>
-          <p:cNvSpPr/>
-          <p:nvPr/>
-        </p:nvSpPr>
-        <p:spPr>
-          <a:xfrm>
-            <a:off x="1626718" y="2752344"/>
-            <a:ext cx="3491271" cy="347472"/>
+            <a:endParaRPr lang="en-US" sz="850" dirty="0"/>
+          </a:p>
+        </p:txBody>
+      </p:sp>
+      <p:sp>
+        <p:nvSpPr>
+          <p:cNvPr id="14" name="Text 10"/>
+          <p:cNvSpPr/>
+          <p:nvPr/>
+        </p:nvSpPr>
+        <p:spPr>
+          <a:xfrm>
+            <a:off x="3392424" y="2478024"/>
+            <a:ext cx="2359152" cy="384048"/>
+          </a:xfrm>
+          <a:prstGeom prst="rect">
+            <a:avLst/>
+          </a:prstGeom>
+          <a:noFill/>
+          <a:ln/>
+        </p:spPr>
+        <p:txBody>
+          <a:bodyPr wrap="square" lIns="0" tIns="0" rIns="0" bIns="0" rtlCol="0" anchor="ctr"/>
+          <a:lstStyle/>
+          <a:p>
+            <a:pPr algn="ctr" indent="0" marL="0">
+              <a:buNone/>
+            </a:pPr>
+            <a:r>
+              <a:rPr lang="en-US" sz="1900" b="1" dirty="0">
+                <a:solidFill>
+                  <a:srgbClr val="0A3D91"/>
+                </a:solidFill>
+                <a:latin typeface="Arial" pitchFamily="34" charset="0"/>
+                <a:ea typeface="Arial" pitchFamily="34" charset="-122"/>
+                <a:cs typeface="Arial" pitchFamily="34" charset="-120"/>
+              </a:rPr>
+              <a:t>137.700+</a:t>
+            </a:r>
+            <a:endParaRPr lang="en-US" sz="1900" dirty="0"/>
+          </a:p>
+        </p:txBody>
+      </p:sp>
+      <p:sp>
+        <p:nvSpPr>
+          <p:cNvPr id="15" name="Text 11"/>
+          <p:cNvSpPr/>
+          <p:nvPr/>
+        </p:nvSpPr>
+        <p:spPr>
+          <a:xfrm>
+            <a:off x="3465576" y="2880360"/>
+            <a:ext cx="2212848" cy="457200"/>
           </a:xfrm>
           <a:prstGeom prst="rect">
             <a:avLst/>
@@ -11240,116 +11328,38 @@
           <a:bodyPr wrap="square" lIns="0" tIns="0" rIns="0" bIns="0" rtlCol="0" anchor="t"/>
           <a:lstStyle/>
           <a:p>
-            <a:pPr indent="0" marL="0">
-              <a:buNone/>
-            </a:pPr>
-            <a:r>
-              <a:rPr lang="en-US" sz="950" b="1" dirty="0">
-                <a:solidFill>
-                  <a:srgbClr val="1D1D1F"/>
-                </a:solidFill>
-                <a:latin typeface="Arial" pitchFamily="34" charset="0"/>
-                <a:ea typeface="Arial" pitchFamily="34" charset="-122"/>
-                <a:cs typeface="Arial" pitchFamily="34" charset="-120"/>
-              </a:rPr>
-              <a:t>Documentación clínica asistida por IA</a:t>
-            </a:r>
-            <a:endParaRPr lang="en-US" sz="950" dirty="0"/>
-          </a:p>
-        </p:txBody>
-      </p:sp>
-      <p:sp>
-        <p:nvSpPr>
-          <p:cNvPr id="12" name="Text 10"/>
-          <p:cNvSpPr/>
-          <p:nvPr/>
-        </p:nvSpPr>
-        <p:spPr>
-          <a:xfrm>
-            <a:off x="1626718" y="3118104"/>
-            <a:ext cx="5890565" cy="256032"/>
-          </a:xfrm>
-          <a:prstGeom prst="rect">
-            <a:avLst/>
-          </a:prstGeom>
-          <a:noFill/>
-          <a:ln/>
-        </p:spPr>
-        <p:txBody>
-          <a:bodyPr wrap="square" lIns="0" tIns="0" rIns="0" bIns="0" rtlCol="0" anchor="ctr"/>
-          <a:lstStyle/>
-          <a:p>
-            <a:pPr indent="0" marL="0">
-              <a:buNone/>
-            </a:pPr>
-            <a:r>
-              <a:rPr lang="en-US" sz="1250" b="1" dirty="0">
-                <a:solidFill>
-                  <a:srgbClr val="0A3D91"/>
-                </a:solidFill>
-                <a:latin typeface="Arial" pitchFamily="34" charset="0"/>
-                <a:ea typeface="Arial" pitchFamily="34" charset="-122"/>
-                <a:cs typeface="Arial" pitchFamily="34" charset="-120"/>
-              </a:rPr>
-              <a:t>137.700+ médicos · 10.839 IPS</a:t>
-            </a:r>
-            <a:endParaRPr lang="en-US" sz="1250" dirty="0"/>
-          </a:p>
-        </p:txBody>
-      </p:sp>
-      <p:sp>
-        <p:nvSpPr>
-          <p:cNvPr id="13" name="Text 11"/>
-          <p:cNvSpPr/>
-          <p:nvPr/>
-        </p:nvSpPr>
-        <p:spPr>
-          <a:xfrm>
-            <a:off x="4889388" y="2551176"/>
-            <a:ext cx="2666061" cy="777240"/>
-          </a:xfrm>
-          <a:prstGeom prst="rect">
-            <a:avLst/>
-          </a:prstGeom>
-          <a:noFill/>
-          <a:ln/>
-        </p:spPr>
-        <p:txBody>
-          <a:bodyPr wrap="square" lIns="0" tIns="0" rIns="0" bIns="0" rtlCol="0" anchor="ctr"/>
-          <a:lstStyle/>
-          <a:p>
-            <a:pPr algn="r" indent="0" marL="0">
-              <a:buNone/>
-            </a:pPr>
-            <a:r>
-              <a:rPr lang="en-US" sz="750" dirty="0">
-                <a:solidFill>
-                  <a:srgbClr val="6E6E73"/>
-                </a:solidFill>
-                <a:latin typeface="Arial" pitchFamily="34" charset="0"/>
-                <a:ea typeface="Arial" pitchFamily="34" charset="-122"/>
-                <a:cs typeface="Arial" pitchFamily="34" charset="-120"/>
-              </a:rPr>
-              <a:t>Médicos activos (2023) e IPS habilitadas (91% privadas, jun 2025)</a:t>
-            </a:r>
-            <a:endParaRPr lang="en-US" sz="750" dirty="0"/>
-          </a:p>
-        </p:txBody>
-      </p:sp>
-      <p:sp>
-        <p:nvSpPr>
-          <p:cNvPr id="14" name="Shape 12"/>
-          <p:cNvSpPr/>
-          <p:nvPr/>
-        </p:nvSpPr>
-        <p:spPr>
-          <a:xfrm>
-            <a:off x="2293315" y="3547872"/>
-            <a:ext cx="4557370" cy="960120"/>
+            <a:pPr algn="ctr" indent="0" marL="0">
+              <a:buNone/>
+            </a:pPr>
+            <a:r>
+              <a:rPr lang="en-US" sz="900" dirty="0">
+                <a:solidFill>
+                  <a:srgbClr val="48484A"/>
+                </a:solidFill>
+                <a:latin typeface="Arial" pitchFamily="34" charset="0"/>
+                <a:ea typeface="Arial" pitchFamily="34" charset="-122"/>
+                <a:cs typeface="Arial" pitchFamily="34" charset="-120"/>
+              </a:rPr>
+              <a:t>médicos activos · 10.839 IPS habilitadas</a:t>
+            </a:r>
+            <a:endParaRPr lang="en-US" sz="900" dirty="0"/>
+          </a:p>
+        </p:txBody>
+      </p:sp>
+      <p:sp>
+        <p:nvSpPr>
+          <p:cNvPr id="16" name="Shape 12"/>
+          <p:cNvSpPr/>
+          <p:nvPr/>
+        </p:nvSpPr>
+        <p:spPr>
+          <a:xfrm>
+            <a:off x="6099048" y="1417320"/>
+            <a:ext cx="2542032" cy="1965960"/>
           </a:xfrm>
           <a:prstGeom prst="roundRect">
             <a:avLst>
-              <a:gd name="adj" fmla="val 8571"/>
+              <a:gd name="adj" fmla="val 4186"/>
             </a:avLst>
           </a:prstGeom>
           <a:solidFill>
@@ -11372,14 +11382,58 @@
       </p:sp>
       <p:sp>
         <p:nvSpPr>
-          <p:cNvPr id="15" name="Text 13"/>
-          <p:cNvSpPr/>
-          <p:nvPr/>
-        </p:nvSpPr>
-        <p:spPr>
-          <a:xfrm>
-            <a:off x="2521915" y="3639312"/>
-            <a:ext cx="2506553" cy="201168"/>
+          <p:cNvPr id="17" name="Shape 13"/>
+          <p:cNvSpPr/>
+          <p:nvPr/>
+        </p:nvSpPr>
+        <p:spPr>
+          <a:xfrm>
+            <a:off x="7114032" y="1618488"/>
+            <a:ext cx="512064" cy="512064"/>
+          </a:xfrm>
+          <a:prstGeom prst="ellipse">
+            <a:avLst/>
+          </a:prstGeom>
+          <a:solidFill>
+            <a:srgbClr val="FFFFFF"/>
+          </a:solidFill>
+          <a:ln/>
+        </p:spPr>
+      </p:sp>
+      <p:pic>
+        <p:nvPicPr>
+          <p:cNvPr id="18" name="Image 2" descr="preencoded.png">    </p:cNvPr>
+          <p:cNvPicPr>
+            <a:picLocks noChangeAspect="1"/>
+          </p:cNvPicPr>
+          <p:nvPr/>
+        </p:nvPicPr>
+        <p:blipFill>
+          <a:blip r:embed="rId3"/>
+          <a:stretch>
+            <a:fillRect/>
+          </a:stretch>
+        </p:blipFill>
+        <p:spPr>
+          <a:xfrm>
+            <a:off x="7185721" y="1690177"/>
+            <a:ext cx="368686" cy="368686"/>
+          </a:xfrm>
+          <a:prstGeom prst="rect">
+            <a:avLst/>
+          </a:prstGeom>
+        </p:spPr>
+      </p:pic>
+      <p:sp>
+        <p:nvSpPr>
+          <p:cNvPr id="19" name="Text 14"/>
+          <p:cNvSpPr/>
+          <p:nvPr/>
+        </p:nvSpPr>
+        <p:spPr>
+          <a:xfrm>
+            <a:off x="6236208" y="2240280"/>
+            <a:ext cx="2267712" cy="219456"/>
           </a:xfrm>
           <a:prstGeom prst="rect">
             <a:avLst/>
@@ -11391,127 +11445,127 @@
           <a:bodyPr wrap="square" lIns="0" tIns="0" rIns="0" bIns="0" rtlCol="0" anchor="ctr"/>
           <a:lstStyle/>
           <a:p>
+            <a:pPr algn="ctr" indent="0" marL="0">
+              <a:buNone/>
+            </a:pPr>
+            <a:r>
+              <a:rPr lang="en-US" sz="850" b="1" spc="100" kern="0" dirty="0">
+                <a:solidFill>
+                  <a:srgbClr val="0071E3"/>
+                </a:solidFill>
+                <a:latin typeface="Arial" pitchFamily="34" charset="0"/>
+                <a:ea typeface="Arial" pitchFamily="34" charset="-122"/>
+                <a:cs typeface="Arial" pitchFamily="34" charset="-120"/>
+              </a:rPr>
+              <a:t>SOM · ANTIOQUIA</a:t>
+            </a:r>
+            <a:endParaRPr lang="en-US" sz="850" dirty="0"/>
+          </a:p>
+        </p:txBody>
+      </p:sp>
+      <p:sp>
+        <p:nvSpPr>
+          <p:cNvPr id="20" name="Text 15"/>
+          <p:cNvSpPr/>
+          <p:nvPr/>
+        </p:nvSpPr>
+        <p:spPr>
+          <a:xfrm>
+            <a:off x="6190488" y="2478024"/>
+            <a:ext cx="2359152" cy="384048"/>
+          </a:xfrm>
+          <a:prstGeom prst="rect">
+            <a:avLst/>
+          </a:prstGeom>
+          <a:noFill/>
+          <a:ln/>
+        </p:spPr>
+        <p:txBody>
+          <a:bodyPr wrap="square" lIns="0" tIns="0" rIns="0" bIns="0" rtlCol="0" anchor="ctr"/>
+          <a:lstStyle/>
+          <a:p>
+            <a:pPr algn="ctr" indent="0" marL="0">
+              <a:buNone/>
+            </a:pPr>
+            <a:r>
+              <a:rPr lang="en-US" sz="1900" b="1" dirty="0">
+                <a:solidFill>
+                  <a:srgbClr val="0A3D91"/>
+                </a:solidFill>
+                <a:latin typeface="Arial" pitchFamily="34" charset="0"/>
+                <a:ea typeface="Arial" pitchFamily="34" charset="-122"/>
+                <a:cs typeface="Arial" pitchFamily="34" charset="-120"/>
+              </a:rPr>
+              <a:t>≈ 940 IPS</a:t>
+            </a:r>
+            <a:endParaRPr lang="en-US" sz="1900" dirty="0"/>
+          </a:p>
+        </p:txBody>
+      </p:sp>
+      <p:sp>
+        <p:nvSpPr>
+          <p:cNvPr id="21" name="Text 16"/>
+          <p:cNvSpPr/>
+          <p:nvPr/>
+        </p:nvSpPr>
+        <p:spPr>
+          <a:xfrm>
+            <a:off x="6263640" y="2880360"/>
+            <a:ext cx="2212848" cy="457200"/>
+          </a:xfrm>
+          <a:prstGeom prst="rect">
+            <a:avLst/>
+          </a:prstGeom>
+          <a:noFill/>
+          <a:ln/>
+        </p:spPr>
+        <p:txBody>
+          <a:bodyPr wrap="square" lIns="0" tIns="0" rIns="0" bIns="0" rtlCol="0" anchor="t"/>
+          <a:lstStyle/>
+          <a:p>
+            <a:pPr algn="ctr" indent="0" marL="0">
+              <a:buNone/>
+            </a:pPr>
+            <a:r>
+              <a:rPr lang="en-US" sz="900" dirty="0">
+                <a:solidFill>
+                  <a:srgbClr val="48484A"/>
+                </a:solidFill>
+                <a:latin typeface="Arial" pitchFamily="34" charset="0"/>
+                <a:ea typeface="Arial" pitchFamily="34" charset="-122"/>
+                <a:cs typeface="Arial" pitchFamily="34" charset="-120"/>
+              </a:rPr>
+              <a:t>Pilotos en Medellín y área metropolitana</a:t>
+            </a:r>
+            <a:endParaRPr lang="en-US" sz="900" dirty="0"/>
+          </a:p>
+        </p:txBody>
+      </p:sp>
+      <p:sp>
+        <p:nvSpPr>
+          <p:cNvPr id="22" name="Text 17"/>
+          <p:cNvSpPr/>
+          <p:nvPr/>
+        </p:nvSpPr>
+        <p:spPr>
+          <a:xfrm>
+            <a:off x="502920" y="3520440"/>
+            <a:ext cx="8138160" cy="365760"/>
+          </a:xfrm>
+          <a:prstGeom prst="rect">
+            <a:avLst/>
+          </a:prstGeom>
+          <a:noFill/>
+          <a:ln/>
+        </p:spPr>
+        <p:txBody>
+          <a:bodyPr wrap="square" lIns="0" tIns="0" rIns="0" bIns="0" rtlCol="0" anchor="ctr"/>
+          <a:lstStyle/>
+          <a:p>
             <a:pPr indent="0" marL="0">
               <a:buNone/>
             </a:pPr>
             <a:r>
-              <a:rPr lang="en-US" sz="800" b="1" spc="100" kern="0" dirty="0">
-                <a:solidFill>
-                  <a:srgbClr val="0071E3"/>
-                </a:solidFill>
-                <a:latin typeface="Arial" pitchFamily="34" charset="0"/>
-                <a:ea typeface="Arial" pitchFamily="34" charset="-122"/>
-                <a:cs typeface="Arial" pitchFamily="34" charset="-120"/>
-              </a:rPr>
-              <a:t>SOM · ANTIOQUIA PRIMERO</a:t>
-            </a:r>
-            <a:endParaRPr lang="en-US" sz="800" dirty="0"/>
-          </a:p>
-        </p:txBody>
-      </p:sp>
-      <p:sp>
-        <p:nvSpPr>
-          <p:cNvPr id="16" name="Text 14"/>
-          <p:cNvSpPr/>
-          <p:nvPr/>
-        </p:nvSpPr>
-        <p:spPr>
-          <a:xfrm>
-            <a:off x="2521915" y="3840480"/>
-            <a:ext cx="2506553" cy="347472"/>
-          </a:xfrm>
-          <a:prstGeom prst="rect">
-            <a:avLst/>
-          </a:prstGeom>
-          <a:noFill/>
-          <a:ln/>
-        </p:spPr>
-        <p:txBody>
-          <a:bodyPr wrap="square" lIns="0" tIns="0" rIns="0" bIns="0" rtlCol="0" anchor="t"/>
-          <a:lstStyle/>
-          <a:p>
-            <a:pPr indent="0" marL="0">
-              <a:buNone/>
-            </a:pPr>
-            <a:r>
-              <a:rPr lang="en-US" sz="950" b="1" dirty="0">
-                <a:solidFill>
-                  <a:srgbClr val="1D1D1F"/>
-                </a:solidFill>
-                <a:latin typeface="Arial" pitchFamily="34" charset="0"/>
-                <a:ea typeface="Arial" pitchFamily="34" charset="-122"/>
-                <a:cs typeface="Arial" pitchFamily="34" charset="-120"/>
-              </a:rPr>
-              <a:t>Pilotos en Medellín y área metropolitana</a:t>
-            </a:r>
-            <a:endParaRPr lang="en-US" sz="950" dirty="0"/>
-          </a:p>
-        </p:txBody>
-      </p:sp>
-      <p:sp>
-        <p:nvSpPr>
-          <p:cNvPr id="17" name="Text 15"/>
-          <p:cNvSpPr/>
-          <p:nvPr/>
-        </p:nvSpPr>
-        <p:spPr>
-          <a:xfrm>
-            <a:off x="2521915" y="4206240"/>
-            <a:ext cx="4100170" cy="256032"/>
-          </a:xfrm>
-          <a:prstGeom prst="rect">
-            <a:avLst/>
-          </a:prstGeom>
-          <a:noFill/>
-          <a:ln/>
-        </p:spPr>
-        <p:txBody>
-          <a:bodyPr wrap="square" lIns="0" tIns="0" rIns="0" bIns="0" rtlCol="0" anchor="ctr"/>
-          <a:lstStyle/>
-          <a:p>
-            <a:pPr indent="0" marL="0">
-              <a:buNone/>
-            </a:pPr>
-            <a:r>
-              <a:rPr lang="en-US" sz="1250" b="1" dirty="0">
-                <a:solidFill>
-                  <a:srgbClr val="0A3D91"/>
-                </a:solidFill>
-                <a:latin typeface="Arial" pitchFamily="34" charset="0"/>
-                <a:ea typeface="Arial" pitchFamily="34" charset="-122"/>
-                <a:cs typeface="Arial" pitchFamily="34" charset="-120"/>
-              </a:rPr>
-              <a:t>≈ 940 IPS</a:t>
-            </a:r>
-            <a:endParaRPr lang="en-US" sz="1250" dirty="0"/>
-          </a:p>
-        </p:txBody>
-      </p:sp>
-      <p:sp>
-        <p:nvSpPr>
-          <p:cNvPr id="18" name="Text 16"/>
-          <p:cNvSpPr/>
-          <p:nvPr/>
-        </p:nvSpPr>
-        <p:spPr>
-          <a:xfrm>
-            <a:off x="4799868" y="3639312"/>
-            <a:ext cx="1914095" cy="777240"/>
-          </a:xfrm>
-          <a:prstGeom prst="rect">
-            <a:avLst/>
-          </a:prstGeom>
-          <a:noFill/>
-          <a:ln/>
-        </p:spPr>
-        <p:txBody>
-          <a:bodyPr wrap="square" lIns="0" tIns="0" rIns="0" bIns="0" rtlCol="0" anchor="ctr"/>
-          <a:lstStyle/>
-          <a:p>
-            <a:pPr algn="r" indent="0" marL="0">
-              <a:buNone/>
-            </a:pPr>
-            <a:r>
               <a:rPr lang="en-US" sz="750" dirty="0">
                 <a:solidFill>
                   <a:srgbClr val="6E6E73"/>
@@ -11520,48 +11574,9 @@
                 <a:ea typeface="Arial" pitchFamily="34" charset="-122"/>
                 <a:cs typeface="Arial" pitchFamily="34" charset="-120"/>
               </a:rPr>
-              <a:t>Consultorios, clínicas e IPS de alto volumen</a:t>
+              <a:t>Fuentes: Market Data Forecast — LatAm Digital Health (CAGR 20,05%); MinSalud 2023; REPS jun 2025 vía Consultorsalud/UNIPS; datos.gov.co — Prestadores de Salud Antioquia.</a:t>
             </a:r>
             <a:endParaRPr lang="en-US" sz="750" dirty="0"/>
-          </a:p>
-        </p:txBody>
-      </p:sp>
-      <p:sp>
-        <p:nvSpPr>
-          <p:cNvPr id="19" name="Text 17"/>
-          <p:cNvSpPr/>
-          <p:nvPr/>
-        </p:nvSpPr>
-        <p:spPr>
-          <a:xfrm>
-            <a:off x="502920" y="4727448"/>
-            <a:ext cx="8138160" cy="457200"/>
-          </a:xfrm>
-          <a:prstGeom prst="rect">
-            <a:avLst/>
-          </a:prstGeom>
-          <a:noFill/>
-          <a:ln/>
-        </p:spPr>
-        <p:txBody>
-          <a:bodyPr wrap="square" lIns="0" tIns="0" rIns="0" bIns="0" rtlCol="0" anchor="ctr"/>
-          <a:lstStyle/>
-          <a:p>
-            <a:pPr indent="0" marL="0">
-              <a:buNone/>
-            </a:pPr>
-            <a:r>
-              <a:rPr lang="en-US" sz="700" dirty="0">
-                <a:solidFill>
-                  <a:srgbClr val="6E6E73"/>
-                </a:solidFill>
-                <a:latin typeface="Arial" pitchFamily="34" charset="0"/>
-                <a:ea typeface="Arial" pitchFamily="34" charset="-122"/>
-                <a:cs typeface="Arial" pitchFamily="34" charset="-120"/>
-              </a:rPr>
-              <a:t>Fuentes: Market Data Forecast — LatAm Digital Health (USD 12,82 mil M en 2024 → USD 66,4 mil M en 2033, CAGR 20,05%); MinSalud 2023 (137.700+ médicos); REPS jun 2025 vía Consultorsalud/UNIPS (10.839 IPS); datos.gov.co — Prestadores de Salud Antioquia.</a:t>
-            </a:r>
-            <a:endParaRPr lang="en-US" sz="700" dirty="0"/>
           </a:p>
         </p:txBody>
       </p:sp>

</xml_diff>